<commit_message>
Complete MVP final acceptance and rehearsal
</commit_message>
<xml_diff>
--- a/docs/presentation/hiraizumi_shigyo_portal_mvp.pptx
+++ b/docs/presentation/hiraizumi_shigyo_portal_mvp.pptx
@@ -2,19 +2,19 @@
 <file path=ppt/presentation.xml><?xml version="1.0" encoding="utf-8"?>
 <p:presentation xmlns:p="http://schemas.openxmlformats.org/presentationml/2006/main">
   <p:sldMasterIdLst>
-    <p:sldMasterId xmlns:r="http://schemas.openxmlformats.org/officeDocument/2006/relationships" id="2147483648" r:id="Rf99a8760f91d4c52"/>
+    <p:sldMasterId xmlns:r="http://schemas.openxmlformats.org/officeDocument/2006/relationships" id="2147483648" r:id="R683a73bef92a4200"/>
   </p:sldMasterIdLst>
   <p:notesMasterIdLst>
-    <p:notesMasterId xmlns:r="http://schemas.openxmlformats.org/officeDocument/2006/relationships" r:id="Rdad7d8c68df44bfc"/>
+    <p:notesMasterId xmlns:r="http://schemas.openxmlformats.org/officeDocument/2006/relationships" r:id="R9c2fb8ff69de4a5e"/>
   </p:notesMasterIdLst>
   <p:sldIdLst>
-    <p:sldId xmlns:r="http://schemas.openxmlformats.org/officeDocument/2006/relationships" id="256" r:id="R8786f9b916ff48e5"/>
-    <p:sldId xmlns:r="http://schemas.openxmlformats.org/officeDocument/2006/relationships" id="257" r:id="Rccb3fd534e054d20"/>
-    <p:sldId xmlns:r="http://schemas.openxmlformats.org/officeDocument/2006/relationships" id="258" r:id="R69abe855632847c5"/>
-    <p:sldId xmlns:r="http://schemas.openxmlformats.org/officeDocument/2006/relationships" id="259" r:id="R3ec18f99da844079"/>
-    <p:sldId xmlns:r="http://schemas.openxmlformats.org/officeDocument/2006/relationships" id="260" r:id="R0a610a9db1b94f0a"/>
-    <p:sldId xmlns:r="http://schemas.openxmlformats.org/officeDocument/2006/relationships" id="261" r:id="R2113af2d537049b2"/>
-    <p:sldId xmlns:r="http://schemas.openxmlformats.org/officeDocument/2006/relationships" id="262" r:id="R77501721c82d4841"/>
+    <p:sldId xmlns:r="http://schemas.openxmlformats.org/officeDocument/2006/relationships" id="256" r:id="Ra944065407644e44"/>
+    <p:sldId xmlns:r="http://schemas.openxmlformats.org/officeDocument/2006/relationships" id="257" r:id="Ra18f1a2fc2734827"/>
+    <p:sldId xmlns:r="http://schemas.openxmlformats.org/officeDocument/2006/relationships" id="258" r:id="Rbe888a9c393249b7"/>
+    <p:sldId xmlns:r="http://schemas.openxmlformats.org/officeDocument/2006/relationships" id="259" r:id="R924de429016646fa"/>
+    <p:sldId xmlns:r="http://schemas.openxmlformats.org/officeDocument/2006/relationships" id="260" r:id="R0e21f23199004170"/>
+    <p:sldId xmlns:r="http://schemas.openxmlformats.org/officeDocument/2006/relationships" id="261" r:id="R407fa649de3b4a43"/>
+    <p:sldId xmlns:r="http://schemas.openxmlformats.org/officeDocument/2006/relationships" id="262" r:id="R4d8bc30573ee408e"/>
   </p:sldIdLst>
   <p:sldSz cx="12192000" cy="6858000"/>
   <p:notesSz cx="6858000" cy="9144000"/>
@@ -453,7 +453,7 @@
           </a:p>
           <a:p xmlns:a="http://schemas.openxmlformats.org/drawingml/2006/main">
             <a:r>
-              <a:t>『平泉町志業シェアハウスを使うには、Wordの申請書を編集して提出します。スマートフォンでは、ここが最初のハードルになります。』</a:t>
+              <a:t>申請書はWord。スマホでの記入が、最初の壁でした。</a:t>
             </a:r>
           </a:p>
           <a:p xmlns:a="http://schemas.openxmlformats.org/drawingml/2006/main">
@@ -463,7 +463,7 @@
           </a:p>
           <a:p xmlns:a="http://schemas.openxmlformats.org/drawingml/2006/main">
             <a:r>
-              <a:t>参照: docs/requirements.md 第2章 / Apple Event風の発表を企画チャット</a:t>
+              <a:t>参照: docs/presentation/presenter_runbook.md / docs/routes.md / docs/a12-integrated-acceptance.md / Issue #79</a:t>
             </a:r>
           </a:p>
         </p:txBody>
@@ -538,7 +538,7 @@
           </a:p>
           <a:p xmlns:a="http://schemas.openxmlformats.org/drawingml/2006/main">
             <a:r>
-              <a:t>『利用者はWordに記入してメールで提出します。町職員は紙の許可通知とExcelの料金管理を使います。一つの申請が複数の場所に分かれ、見落としや転記、進捗確認の手間が生まれます。』</a:t>
+              <a:t>Wordで記入し、メールで提出。職員は紙で許可し、Excelで料金を管理します。一つの申請が四か所に分かれるため、転記や状況確認に手間がかかります。</a:t>
             </a:r>
           </a:p>
           <a:p xmlns:a="http://schemas.openxmlformats.org/drawingml/2006/main">
@@ -548,7 +548,7 @@
           </a:p>
           <a:p xmlns:a="http://schemas.openxmlformats.org/drawingml/2006/main">
             <a:r>
-              <a:t>参照: docs/requirements.md 第2章</a:t>
+              <a:t>参照: docs/presentation/presenter_runbook.md / docs/routes.md / docs/a12-integrated-acceptance.md / Issue #79</a:t>
             </a:r>
           </a:p>
         </p:txBody>
@@ -623,7 +623,7 @@
           </a:p>
           <a:p xmlns:a="http://schemas.openxmlformats.org/drawingml/2006/main">
             <a:r>
-              <a:t>『では、利用者と町職員が同じ申請情報を同じ場所で確認できたらどうでしょう。その答えとして制作したのが、ひらいずみ志業ポータルです。申請から審査、部屋、料金、納付、入退去までを一つの流れで扱います。』</a:t>
+              <a:t>そこで作ったのが、ひらいずみ志業ポータルです。利用者と職員が同じ申請を見ながら、審査、部屋、料金、入退去を確認します。自主制作の試作版です。</a:t>
             </a:r>
           </a:p>
           <a:p xmlns:a="http://schemas.openxmlformats.org/drawingml/2006/main">
@@ -633,7 +633,7 @@
           </a:p>
           <a:p xmlns:a="http://schemas.openxmlformats.org/drawingml/2006/main">
             <a:r>
-              <a:t>参照: README.md / docs/requirements.md 第1章・第5章 / Issue #85</a:t>
+              <a:t>参照: docs/presentation/presenter_runbook.md / docs/routes.md / docs/a12-integrated-acceptance.md / Issue #79</a:t>
             </a:r>
           </a:p>
         </p:txBody>
@@ -708,7 +708,7 @@
           </a:p>
           <a:p xmlns:a="http://schemas.openxmlformats.org/drawingml/2006/main">
             <a:r>
-              <a:t>『公開本番ではトップとカレンダーを確認できます。現在のmainには、対象者名簿、事前部屋案、本人の部屋表示、申請PDFの確認提出、再審査、職員用配置表PDFまで統合されています。SQL037〜040は本番反映済みですが、常設Linux変換先が未指定なのでPDF生成は安全側に停止しています。』</a:t>
+              <a:t>コードとDBは反映済みです。公開画面から流れをご覧ください。本番のPDF生成は停止中です。</a:t>
             </a:r>
           </a:p>
           <a:p xmlns:a="http://schemas.openxmlformats.org/drawingml/2006/main">
@@ -718,7 +718,7 @@
           </a:p>
           <a:p xmlns:a="http://schemas.openxmlformats.org/drawingml/2006/main">
             <a:r>
-              <a:t>参照: main 48ac7fd / docs/routes.md / docs/camp-pdf-confirm-submit.md / docs/staff-room-plan-pdf.md</a:t>
+              <a:t>参照: docs/presentation/presenter_runbook.md / docs/routes.md / docs/a12-integrated-acceptance.md / Issue #79</a:t>
             </a:r>
           </a:p>
         </p:txBody>
@@ -793,32 +793,37 @@
           </a:p>
           <a:p xmlns:a="http://schemas.openxmlformats.org/drawingml/2006/main">
             <a:r>
-              <a:t>0:00 公開カレンダーで表示が利用可否だけであることを確認。</a:t>
-            </a:r>
-          </a:p>
-          <a:p xmlns:a="http://schemas.openxmlformats.org/drawingml/2006/main">
-            <a:r>
-              <a:t>0:30 利用者の申請一覧と詳細で、受付番号、状態、料金を確認。</a:t>
-            </a:r>
-          </a:p>
-          <a:p xmlns:a="http://schemas.openxmlformats.org/drawingml/2006/main">
-            <a:r>
-              <a:t>1:10 利用者の『自分の部屋』で、本人の割当だけを表示することを説明。</a:t>
-            </a:r>
-          </a:p>
-          <a:p xmlns:a="http://schemas.openxmlformats.org/drawingml/2006/main">
-            <a:r>
-              <a:t>1:50 職員の対象者名簿と事前部屋案を確認し、発表中は保存しない。</a:t>
-            </a:r>
-          </a:p>
-          <a:p xmlns:a="http://schemas.openxmlformats.org/drawingml/2006/main">
-            <a:r>
-              <a:t>2:40 利用者と職員が一つの申請を共有して進められるとまとめる。</a:t>
-            </a:r>
-          </a:p>
-          <a:p xmlns:a="http://schemas.openxmlformats.org/drawingml/2006/main">
-            <a:r>
-              <a:t>通信待ちが8秒を超えたら『ここからは、同じ流れを事前に用意した資料でご覧ください』と言い、fallback_demo.pdfを開く。</a:t>
+              <a:t>0:00 公開カレンダー。</a:t>
+            </a:r>
+          </a:p>
+          <a:p xmlns:a="http://schemas.openxmlformats.org/drawingml/2006/main">
+            <a:r>
+              <a:t>0:30 利用者の申請状況。</a:t>
+            </a:r>
+          </a:p>
+          <a:p xmlns:a="http://schemas.openxmlformats.org/drawingml/2006/main">
+            <a:r>
+              <a:t>1:10 本人の部屋と職員の部屋案。</a:t>
+            </a:r>
+          </a:p>
+          <a:p xmlns:a="http://schemas.openxmlformats.org/drawingml/2006/main">
+            <a:r>
+              <a:t>1:50 職員の申請詳細。</a:t>
+            </a:r>
+          </a:p>
+          <a:p xmlns:a="http://schemas.openxmlformats.org/drawingml/2006/main">
+            <a:r>
+              <a:t>2:40 まとめてスライド6へ。</a:t>
+            </a:r>
+          </a:p>
+          <a:p xmlns:a="http://schemas.openxmlformats.org/drawingml/2006/main">
+            <a:r>
+              <a:t>準備済みの架空データと職員セッションがない場合は、認証画面の説明をSTATIC FALLBACK資料へ切り替え、本番画面とは説明しない。通信待ちが8秒を超えたら「ここからは、同じ流れを事前に用意した資料でご覧ください」と言い、fallback_demo.pdfへ切り替える。</a:t>
+            </a:r>
+          </a:p>
+          <a:p xmlns:a="http://schemas.openxmlformats.org/drawingml/2006/main">
+            <a:r>
+              <a:t>発表中は保存・提出・審査・納付を実行しない。</a:t>
             </a:r>
           </a:p>
           <a:p xmlns:a="http://schemas.openxmlformats.org/drawingml/2006/main">
@@ -828,7 +833,7 @@
           </a:p>
           <a:p xmlns:a="http://schemas.openxmlformats.org/drawingml/2006/main">
             <a:r>
-              <a:t>参照: docs/demo-runbook.md / docs/presentation/presenter_runbook.md</a:t>
+              <a:t>参照: docs/presentation/presenter_runbook.md / docs/routes.md / docs/a12-integrated-acceptance.md / Issue #79</a:t>
             </a:r>
           </a:p>
         </p:txBody>
@@ -903,7 +908,7 @@
           </a:p>
           <a:p xmlns:a="http://schemas.openxmlformats.org/drawingml/2006/main">
             <a:r>
-              <a:t>『こだわったのは画面の裏側です。利用者は自分の申請だけを見られるようにし、職員操作もサーバーとDBで権限を確認します。施設全体と各部屋の定員は同時操作でも超えないようDBで検査します。審査、納付、入退去を分け、操作履歴も残します。』</a:t>
+              <a:t>利用者が見られるのは本人の申請です。職員操作もサーバーとDBで権限を確認します。施設と部屋の定員を同時操作でも守り、審査、納付、入退去を分けて記録します。画面だけでなく、データの整合性にも取り組みました。</a:t>
             </a:r>
           </a:p>
           <a:p xmlns:a="http://schemas.openxmlformats.org/drawingml/2006/main">
@@ -913,7 +918,7 @@
           </a:p>
           <a:p xmlns:a="http://schemas.openxmlformats.org/drawingml/2006/main">
             <a:r>
-              <a:t>参照: docs/requirements.md 第5章・第6章 / docs/database.md / docs/mvp-acceptance.md</a:t>
+              <a:t>参照: docs/presentation/presenter_runbook.md / docs/routes.md / docs/a12-integrated-acceptance.md / Issue #79</a:t>
             </a:r>
           </a:p>
         </p:txBody>
@@ -988,7 +993,7 @@
           </a:p>
           <a:p xmlns:a="http://schemas.openxmlformats.org/drawingml/2006/main">
             <a:r>
-              <a:t>『事前部屋案、申請PDFの確認提出、再審査、職員用配置表PDF、A12総合受入はmainへ統合され、SQL037〜040も本番反映済みです。ただし常設Linux変換先が未指定で、PDF生成active設定は0のため、本番のPDF生成は安全側に停止しています。平泉で始める、その一歩を、手続きで止めない。これが、ひらいずみ志業ポータルです。ありがとうございました。』</a:t>
+              <a:t>PDFは常設の変換先がないため、本番生成を停止しています。同意書アップロードはMVP対象外です。平泉で始める、その一歩を、手続きで止めない。これが、ひらいずみ志業ポータルです。</a:t>
             </a:r>
           </a:p>
           <a:p xmlns:a="http://schemas.openxmlformats.org/drawingml/2006/main">
@@ -998,7 +1003,7 @@
           </a:p>
           <a:p xmlns:a="http://schemas.openxmlformats.org/drawingml/2006/main">
             <a:r>
-              <a:t>参照: main 48ac7fd / docs/a12-integrated-acceptance.md / docs/camp-pdf-confirm-submit.md / docs/staff-room-plan-pdf.md / Issue #88</a:t>
+              <a:t>参照: docs/presentation/presenter_runbook.md / docs/routes.md / docs/a12-integrated-acceptance.md / Issue #79</a:t>
             </a:r>
           </a:p>
         </p:txBody>
@@ -1066,7 +1071,7 @@
   </p:cSld>
   <p:clrMap bg1="lt1" tx1="dk1" bg2="lt2" tx2="dk2" accent1="accent1" accent2="accent2" accent3="accent3" accent4="accent4" accent5="accent5" accent6="accent6" hlink="hlink" folHlink="folHlink"/>
   <p:sldLayoutIdLst>
-    <p:sldLayoutId xmlns:r="http://schemas.openxmlformats.org/officeDocument/2006/relationships" id="2147483649" r:id="Rdba5b646f06a4552"/>
+    <p:sldLayoutId xmlns:r="http://schemas.openxmlformats.org/officeDocument/2006/relationships" id="2147483649" r:id="R95cf964561a54022"/>
   </p:sldLayoutIdLst>
   <p:txStyles>
     <p:titleStyle>
@@ -1646,6 +1651,7 @@
           <a:lstStyle xmlns:a="http://schemas.openxmlformats.org/drawingml/2006/main"/>
           <a:p xmlns:a="http://schemas.openxmlformats.org/drawingml/2006/main">
             <a:pPr algn="l">
+              <a:buNone/>
               <a:defRPr sz="4350" b="1">
                 <a:solidFill>
                   <a:srgbClr val="111111"/>
@@ -1703,6 +1709,7 @@
           <a:lstStyle xmlns:a="http://schemas.openxmlformats.org/drawingml/2006/main"/>
           <a:p xmlns:a="http://schemas.openxmlformats.org/drawingml/2006/main">
             <a:pPr algn="l">
+              <a:buNone/>
               <a:defRPr sz="6600" b="1">
                 <a:solidFill>
                   <a:srgbClr val="FF5A36"/>
@@ -1760,6 +1767,7 @@
           <a:lstStyle xmlns:a="http://schemas.openxmlformats.org/drawingml/2006/main"/>
           <a:p xmlns:a="http://schemas.openxmlformats.org/drawingml/2006/main">
             <a:pPr algn="l">
+              <a:buNone/>
               <a:defRPr sz="1575" b="0">
                 <a:solidFill>
                   <a:srgbClr val="77736B"/>
@@ -1817,6 +1825,7 @@
           <a:lstStyle xmlns:a="http://schemas.openxmlformats.org/drawingml/2006/main"/>
           <a:p xmlns:a="http://schemas.openxmlformats.org/drawingml/2006/main">
             <a:pPr algn="l">
+              <a:buNone/>
               <a:defRPr sz="900" b="0">
                 <a:solidFill>
                   <a:srgbClr val="77736B"/>
@@ -1874,6 +1883,7 @@
           <a:lstStyle xmlns:a="http://schemas.openxmlformats.org/drawingml/2006/main"/>
           <a:p xmlns:a="http://schemas.openxmlformats.org/drawingml/2006/main">
             <a:pPr algn="l">
+              <a:buNone/>
               <a:defRPr sz="675" b="0">
                 <a:solidFill>
                   <a:srgbClr val="8C887F"/>
@@ -1931,6 +1941,7 @@
           <a:lstStyle xmlns:a="http://schemas.openxmlformats.org/drawingml/2006/main"/>
           <a:p xmlns:a="http://schemas.openxmlformats.org/drawingml/2006/main">
             <a:pPr algn="r">
+              <a:buNone/>
               <a:defRPr sz="675" b="0">
                 <a:solidFill>
                   <a:srgbClr val="8C887F"/>
@@ -2017,6 +2028,7 @@
           <a:lstStyle xmlns:a="http://schemas.openxmlformats.org/drawingml/2006/main"/>
           <a:p xmlns:a="http://schemas.openxmlformats.org/drawingml/2006/main">
             <a:pPr algn="l">
+              <a:buNone/>
               <a:defRPr sz="4350" b="1">
                 <a:solidFill>
                   <a:srgbClr val="111111"/>
@@ -2040,6 +2052,7 @@
           </a:p>
           <a:p xmlns:a="http://schemas.openxmlformats.org/drawingml/2006/main">
             <a:pPr algn="l">
+              <a:buNone/>
               <a:defRPr sz="4350" b="1">
                 <a:solidFill>
                   <a:srgbClr val="111111"/>
@@ -2097,6 +2110,7 @@
           <a:lstStyle xmlns:a="http://schemas.openxmlformats.org/drawingml/2006/main"/>
           <a:p xmlns:a="http://schemas.openxmlformats.org/drawingml/2006/main">
             <a:pPr algn="l">
+              <a:buNone/>
               <a:defRPr sz="2700" b="1">
                 <a:solidFill>
                   <a:srgbClr val="FF5A36"/>
@@ -2184,6 +2198,7 @@
           <a:lstStyle xmlns:a="http://schemas.openxmlformats.org/drawingml/2006/main"/>
           <a:p xmlns:a="http://schemas.openxmlformats.org/drawingml/2006/main">
             <a:pPr algn="l">
+              <a:buNone/>
               <a:defRPr sz="1575" b="0">
                 <a:solidFill>
                   <a:srgbClr val="5D5A54"/>
@@ -2241,6 +2256,7 @@
           <a:lstStyle xmlns:a="http://schemas.openxmlformats.org/drawingml/2006/main"/>
           <a:p xmlns:a="http://schemas.openxmlformats.org/drawingml/2006/main">
             <a:pPr algn="l">
+              <a:buNone/>
               <a:defRPr sz="2700" b="1">
                 <a:solidFill>
                   <a:srgbClr val="111111"/>
@@ -2328,6 +2344,7 @@
           <a:lstStyle xmlns:a="http://schemas.openxmlformats.org/drawingml/2006/main"/>
           <a:p xmlns:a="http://schemas.openxmlformats.org/drawingml/2006/main">
             <a:pPr algn="l">
+              <a:buNone/>
               <a:defRPr sz="1575" b="0">
                 <a:solidFill>
                   <a:srgbClr val="5D5A54"/>
@@ -2385,6 +2402,7 @@
           <a:lstStyle xmlns:a="http://schemas.openxmlformats.org/drawingml/2006/main"/>
           <a:p xmlns:a="http://schemas.openxmlformats.org/drawingml/2006/main">
             <a:pPr algn="l">
+              <a:buNone/>
               <a:defRPr sz="2700" b="1">
                 <a:solidFill>
                   <a:srgbClr val="111111"/>
@@ -2472,6 +2490,7 @@
           <a:lstStyle xmlns:a="http://schemas.openxmlformats.org/drawingml/2006/main"/>
           <a:p xmlns:a="http://schemas.openxmlformats.org/drawingml/2006/main">
             <a:pPr algn="l">
+              <a:buNone/>
               <a:defRPr sz="1575" b="0">
                 <a:solidFill>
                   <a:srgbClr val="5D5A54"/>
@@ -2529,6 +2548,7 @@
           <a:lstStyle xmlns:a="http://schemas.openxmlformats.org/drawingml/2006/main"/>
           <a:p xmlns:a="http://schemas.openxmlformats.org/drawingml/2006/main">
             <a:pPr algn="l">
+              <a:buNone/>
               <a:defRPr sz="2700" b="1">
                 <a:solidFill>
                   <a:srgbClr val="111111"/>
@@ -2616,6 +2636,7 @@
           <a:lstStyle xmlns:a="http://schemas.openxmlformats.org/drawingml/2006/main"/>
           <a:p xmlns:a="http://schemas.openxmlformats.org/drawingml/2006/main">
             <a:pPr algn="l">
+              <a:buNone/>
               <a:defRPr sz="1575" b="0">
                 <a:solidFill>
                   <a:srgbClr val="5D5A54"/>
@@ -2673,6 +2694,7 @@
           <a:lstStyle xmlns:a="http://schemas.openxmlformats.org/drawingml/2006/main"/>
           <a:p xmlns:a="http://schemas.openxmlformats.org/drawingml/2006/main">
             <a:pPr algn="l">
+              <a:buNone/>
               <a:defRPr sz="2025" b="1">
                 <a:solidFill>
                   <a:srgbClr val="111111"/>
@@ -2730,6 +2752,7 @@
           <a:lstStyle xmlns:a="http://schemas.openxmlformats.org/drawingml/2006/main"/>
           <a:p xmlns:a="http://schemas.openxmlformats.org/drawingml/2006/main">
             <a:pPr algn="l">
+              <a:buNone/>
               <a:defRPr sz="675" b="0">
                 <a:solidFill>
                   <a:srgbClr val="8C887F"/>
@@ -2787,6 +2810,7 @@
           <a:lstStyle xmlns:a="http://schemas.openxmlformats.org/drawingml/2006/main"/>
           <a:p xmlns:a="http://schemas.openxmlformats.org/drawingml/2006/main">
             <a:pPr algn="r">
+              <a:buNone/>
               <a:defRPr sz="675" b="0">
                 <a:solidFill>
                   <a:srgbClr val="8C887F"/>
@@ -2873,6 +2897,7 @@
           <a:lstStyle xmlns:a="http://schemas.openxmlformats.org/drawingml/2006/main"/>
           <a:p xmlns:a="http://schemas.openxmlformats.org/drawingml/2006/main">
             <a:pPr algn="l">
+              <a:buNone/>
               <a:defRPr sz="1875" b="0">
                 <a:solidFill>
                   <a:srgbClr val="AAA9A4"/>
@@ -2930,6 +2955,7 @@
           <a:lstStyle xmlns:a="http://schemas.openxmlformats.org/drawingml/2006/main"/>
           <a:p xmlns:a="http://schemas.openxmlformats.org/drawingml/2006/main">
             <a:pPr algn="l">
+              <a:buNone/>
               <a:defRPr sz="5700" b="1">
                 <a:solidFill>
                   <a:srgbClr val="FFFFFF"/>
@@ -2953,6 +2979,7 @@
           </a:p>
           <a:p xmlns:a="http://schemas.openxmlformats.org/drawingml/2006/main">
             <a:pPr algn="l">
+              <a:buNone/>
               <a:defRPr sz="5700" b="1">
                 <a:solidFill>
                   <a:srgbClr val="FFFFFF"/>
@@ -3040,6 +3067,7 @@
           <a:lstStyle xmlns:a="http://schemas.openxmlformats.org/drawingml/2006/main"/>
           <a:p xmlns:a="http://schemas.openxmlformats.org/drawingml/2006/main">
             <a:pPr algn="l">
+              <a:buNone/>
               <a:defRPr sz="2325" b="1">
                 <a:solidFill>
                   <a:srgbClr val="FF5A36"/>
@@ -3097,6 +3125,7 @@
           <a:lstStyle xmlns:a="http://schemas.openxmlformats.org/drawingml/2006/main"/>
           <a:p xmlns:a="http://schemas.openxmlformats.org/drawingml/2006/main">
             <a:pPr algn="l">
+              <a:buNone/>
               <a:defRPr sz="1350" b="0">
                 <a:solidFill>
                   <a:srgbClr val="9C9C97"/>
@@ -3154,6 +3183,7 @@
           <a:lstStyle xmlns:a="http://schemas.openxmlformats.org/drawingml/2006/main"/>
           <a:p xmlns:a="http://schemas.openxmlformats.org/drawingml/2006/main">
             <a:pPr algn="l">
+              <a:buNone/>
               <a:defRPr sz="900" b="0">
                 <a:solidFill>
                   <a:srgbClr val="9C9C97"/>
@@ -3211,6 +3241,7 @@
           <a:lstStyle xmlns:a="http://schemas.openxmlformats.org/drawingml/2006/main"/>
           <a:p xmlns:a="http://schemas.openxmlformats.org/drawingml/2006/main">
             <a:pPr algn="l">
+              <a:buNone/>
               <a:defRPr sz="675" b="0">
                 <a:solidFill>
                   <a:srgbClr val="777772"/>
@@ -3268,6 +3299,7 @@
           <a:lstStyle xmlns:a="http://schemas.openxmlformats.org/drawingml/2006/main"/>
           <a:p xmlns:a="http://schemas.openxmlformats.org/drawingml/2006/main">
             <a:pPr algn="r">
+              <a:buNone/>
               <a:defRPr sz="675" b="0">
                 <a:solidFill>
                   <a:srgbClr val="777772"/>
@@ -3354,6 +3386,7 @@
           <a:lstStyle xmlns:a="http://schemas.openxmlformats.org/drawingml/2006/main"/>
           <a:p xmlns:a="http://schemas.openxmlformats.org/drawingml/2006/main">
             <a:pPr algn="l">
+              <a:buNone/>
               <a:defRPr sz="3225" b="1">
                 <a:solidFill>
                   <a:srgbClr val="111111"/>
@@ -3411,6 +3444,7 @@
           <a:lstStyle xmlns:a="http://schemas.openxmlformats.org/drawingml/2006/main"/>
           <a:p xmlns:a="http://schemas.openxmlformats.org/drawingml/2006/main">
             <a:pPr algn="l">
+              <a:buNone/>
               <a:defRPr sz="2175" b="1">
                 <a:solidFill>
                   <a:srgbClr val="FF5A36"/>
@@ -3468,6 +3502,7 @@
           <a:lstStyle xmlns:a="http://schemas.openxmlformats.org/drawingml/2006/main"/>
           <a:p xmlns:a="http://schemas.openxmlformats.org/drawingml/2006/main">
             <a:pPr algn="l">
+              <a:buNone/>
               <a:defRPr sz="1800" b="0">
                 <a:solidFill>
                   <a:srgbClr val="111111"/>
@@ -3491,6 +3526,7 @@
           </a:p>
           <a:p xmlns:a="http://schemas.openxmlformats.org/drawingml/2006/main">
             <a:pPr algn="l">
+              <a:buNone/>
               <a:defRPr sz="1800" b="0">
                 <a:solidFill>
                   <a:srgbClr val="111111"/>
@@ -3514,6 +3550,7 @@
           </a:p>
           <a:p xmlns:a="http://schemas.openxmlformats.org/drawingml/2006/main">
             <a:pPr algn="l">
+              <a:buNone/>
               <a:defRPr sz="1800" b="0">
                 <a:solidFill>
                   <a:srgbClr val="111111"/>
@@ -3537,6 +3574,7 @@
           </a:p>
           <a:p xmlns:a="http://schemas.openxmlformats.org/drawingml/2006/main">
             <a:pPr algn="l">
+              <a:buNone/>
               <a:defRPr sz="1800" b="0">
                 <a:solidFill>
                   <a:srgbClr val="111111"/>
@@ -3624,6 +3662,7 @@
           <a:lstStyle xmlns:a="http://schemas.openxmlformats.org/drawingml/2006/main"/>
           <a:p xmlns:a="http://schemas.openxmlformats.org/drawingml/2006/main">
             <a:pPr algn="l">
+              <a:buNone/>
               <a:defRPr sz="2175" b="1">
                 <a:solidFill>
                   <a:srgbClr val="111111"/>
@@ -3681,6 +3720,7 @@
           <a:lstStyle xmlns:a="http://schemas.openxmlformats.org/drawingml/2006/main"/>
           <a:p xmlns:a="http://schemas.openxmlformats.org/drawingml/2006/main">
             <a:pPr algn="l">
+              <a:buNone/>
               <a:defRPr sz="1800" b="0">
                 <a:solidFill>
                   <a:srgbClr val="111111"/>
@@ -3704,6 +3744,7 @@
           </a:p>
           <a:p xmlns:a="http://schemas.openxmlformats.org/drawingml/2006/main">
             <a:pPr algn="l">
+              <a:buNone/>
               <a:defRPr sz="1800" b="0">
                 <a:solidFill>
                   <a:srgbClr val="111111"/>
@@ -3727,6 +3768,7 @@
           </a:p>
           <a:p xmlns:a="http://schemas.openxmlformats.org/drawingml/2006/main">
             <a:pPr algn="l">
+              <a:buNone/>
               <a:defRPr sz="1800" b="0">
                 <a:solidFill>
                   <a:srgbClr val="111111"/>
@@ -3750,6 +3792,7 @@
           </a:p>
           <a:p xmlns:a="http://schemas.openxmlformats.org/drawingml/2006/main">
             <a:pPr algn="l">
+              <a:buNone/>
               <a:defRPr sz="1800" b="0">
                 <a:solidFill>
                   <a:srgbClr val="111111"/>
@@ -3807,6 +3850,7 @@
           <a:lstStyle xmlns:a="http://schemas.openxmlformats.org/drawingml/2006/main"/>
           <a:p xmlns:a="http://schemas.openxmlformats.org/drawingml/2006/main">
             <a:pPr algn="l">
+              <a:buNone/>
               <a:defRPr sz="2025" b="1">
                 <a:solidFill>
                   <a:srgbClr val="2F69A7"/>
@@ -3864,6 +3908,7 @@
           <a:lstStyle xmlns:a="http://schemas.openxmlformats.org/drawingml/2006/main"/>
           <a:p xmlns:a="http://schemas.openxmlformats.org/drawingml/2006/main">
             <a:pPr algn="l">
+              <a:buNone/>
               <a:defRPr sz="675" b="0">
                 <a:solidFill>
                   <a:srgbClr val="8C887F"/>
@@ -3921,6 +3966,7 @@
           <a:lstStyle xmlns:a="http://schemas.openxmlformats.org/drawingml/2006/main"/>
           <a:p xmlns:a="http://schemas.openxmlformats.org/drawingml/2006/main">
             <a:pPr algn="r">
+              <a:buNone/>
               <a:defRPr sz="675" b="0">
                 <a:solidFill>
                   <a:srgbClr val="8C887F"/>
@@ -4007,6 +4053,7 @@
           <a:lstStyle xmlns:a="http://schemas.openxmlformats.org/drawingml/2006/main"/>
           <a:p xmlns:a="http://schemas.openxmlformats.org/drawingml/2006/main">
             <a:pPr algn="l">
+              <a:buNone/>
               <a:defRPr sz="4575" b="1">
                 <a:solidFill>
                   <a:srgbClr val="FF5A36"/>
@@ -4064,6 +4111,7 @@
           <a:lstStyle xmlns:a="http://schemas.openxmlformats.org/drawingml/2006/main"/>
           <a:p xmlns:a="http://schemas.openxmlformats.org/drawingml/2006/main">
             <a:pPr algn="l">
+              <a:buNone/>
               <a:defRPr sz="2550" b="1">
                 <a:solidFill>
                   <a:srgbClr val="FFFFFF"/>
@@ -4183,6 +4231,7 @@
           <a:lstStyle xmlns:a="http://schemas.openxmlformats.org/drawingml/2006/main"/>
           <a:p xmlns:a="http://schemas.openxmlformats.org/drawingml/2006/main">
             <a:pPr algn="l">
+              <a:buNone/>
               <a:defRPr sz="1650" b="1">
                 <a:solidFill>
                   <a:srgbClr val="111111"/>
@@ -4240,6 +4289,7 @@
           <a:lstStyle xmlns:a="http://schemas.openxmlformats.org/drawingml/2006/main"/>
           <a:p xmlns:a="http://schemas.openxmlformats.org/drawingml/2006/main">
             <a:pPr algn="l">
+              <a:buNone/>
               <a:defRPr sz="1650" b="1">
                 <a:solidFill>
                   <a:srgbClr val="FFFFFF"/>
@@ -4329,6 +4379,7 @@
           <a:lstStyle xmlns:a="http://schemas.openxmlformats.org/drawingml/2006/main"/>
           <a:p xmlns:a="http://schemas.openxmlformats.org/drawingml/2006/main">
             <a:pPr algn="l">
+              <a:buNone/>
               <a:defRPr sz="1650" b="1">
                 <a:solidFill>
                   <a:srgbClr val="111111"/>
@@ -4386,6 +4437,7 @@
           <a:lstStyle xmlns:a="http://schemas.openxmlformats.org/drawingml/2006/main"/>
           <a:p xmlns:a="http://schemas.openxmlformats.org/drawingml/2006/main">
             <a:pPr algn="l">
+              <a:buNone/>
               <a:defRPr sz="1650" b="1">
                 <a:solidFill>
                   <a:srgbClr val="FFFFFF"/>
@@ -4475,6 +4527,7 @@
           <a:lstStyle xmlns:a="http://schemas.openxmlformats.org/drawingml/2006/main"/>
           <a:p xmlns:a="http://schemas.openxmlformats.org/drawingml/2006/main">
             <a:pPr algn="l">
+              <a:buNone/>
               <a:defRPr sz="1650" b="1">
                 <a:solidFill>
                   <a:srgbClr val="111111"/>
@@ -4532,6 +4585,7 @@
           <a:lstStyle xmlns:a="http://schemas.openxmlformats.org/drawingml/2006/main"/>
           <a:p xmlns:a="http://schemas.openxmlformats.org/drawingml/2006/main">
             <a:pPr algn="l">
+              <a:buNone/>
               <a:defRPr sz="1650" b="1">
                 <a:solidFill>
                   <a:srgbClr val="FFFFFF"/>
@@ -4621,6 +4675,7 @@
           <a:lstStyle xmlns:a="http://schemas.openxmlformats.org/drawingml/2006/main"/>
           <a:p xmlns:a="http://schemas.openxmlformats.org/drawingml/2006/main">
             <a:pPr algn="l">
+              <a:buNone/>
               <a:defRPr sz="1650" b="1">
                 <a:solidFill>
                   <a:srgbClr val="111111"/>
@@ -4678,6 +4733,7 @@
           <a:lstStyle xmlns:a="http://schemas.openxmlformats.org/drawingml/2006/main"/>
           <a:p xmlns:a="http://schemas.openxmlformats.org/drawingml/2006/main">
             <a:pPr algn="l">
+              <a:buNone/>
               <a:defRPr sz="1650" b="1">
                 <a:solidFill>
                   <a:srgbClr val="FF5A36"/>
@@ -4735,6 +4791,7 @@
           <a:lstStyle xmlns:a="http://schemas.openxmlformats.org/drawingml/2006/main"/>
           <a:p xmlns:a="http://schemas.openxmlformats.org/drawingml/2006/main">
             <a:pPr algn="l">
+              <a:buNone/>
               <a:defRPr sz="1875" b="1">
                 <a:solidFill>
                   <a:srgbClr val="9C9C97"/>
@@ -4792,6 +4849,7 @@
           <a:lstStyle xmlns:a="http://schemas.openxmlformats.org/drawingml/2006/main"/>
           <a:p xmlns:a="http://schemas.openxmlformats.org/drawingml/2006/main">
             <a:pPr algn="l">
+              <a:buNone/>
               <a:defRPr sz="1575" b="0">
                 <a:solidFill>
                   <a:srgbClr val="A6A5A0"/>
@@ -4849,6 +4907,7 @@
           <a:lstStyle xmlns:a="http://schemas.openxmlformats.org/drawingml/2006/main"/>
           <a:p xmlns:a="http://schemas.openxmlformats.org/drawingml/2006/main">
             <a:pPr algn="l">
+              <a:buNone/>
               <a:defRPr sz="675" b="0">
                 <a:solidFill>
                   <a:srgbClr val="777772"/>
@@ -4906,6 +4965,7 @@
           <a:lstStyle xmlns:a="http://schemas.openxmlformats.org/drawingml/2006/main"/>
           <a:p xmlns:a="http://schemas.openxmlformats.org/drawingml/2006/main">
             <a:pPr algn="r">
+              <a:buNone/>
               <a:defRPr sz="675" b="0">
                 <a:solidFill>
                   <a:srgbClr val="777772"/>
@@ -4992,6 +5052,7 @@
           <a:lstStyle xmlns:a="http://schemas.openxmlformats.org/drawingml/2006/main"/>
           <a:p xmlns:a="http://schemas.openxmlformats.org/drawingml/2006/main">
             <a:pPr algn="l">
+              <a:buNone/>
               <a:defRPr sz="3225" b="1">
                 <a:solidFill>
                   <a:srgbClr val="111111"/>
@@ -5049,6 +5110,7 @@
           <a:lstStyle xmlns:a="http://schemas.openxmlformats.org/drawingml/2006/main"/>
           <a:p xmlns:a="http://schemas.openxmlformats.org/drawingml/2006/main">
             <a:pPr algn="l">
+              <a:buNone/>
               <a:defRPr sz="2100" b="1">
                 <a:solidFill>
                   <a:srgbClr val="FF5A36"/>
@@ -5136,6 +5198,7 @@
           <a:lstStyle xmlns:a="http://schemas.openxmlformats.org/drawingml/2006/main"/>
           <a:p xmlns:a="http://schemas.openxmlformats.org/drawingml/2006/main">
             <a:pPr algn="l">
+              <a:buNone/>
               <a:defRPr sz="1650" b="0">
                 <a:solidFill>
                   <a:srgbClr val="111111"/>
@@ -5159,6 +5222,7 @@
           </a:p>
           <a:p xmlns:a="http://schemas.openxmlformats.org/drawingml/2006/main">
             <a:pPr algn="l">
+              <a:buNone/>
               <a:defRPr sz="1650" b="0">
                 <a:solidFill>
                   <a:srgbClr val="111111"/>
@@ -5216,6 +5280,7 @@
           <a:lstStyle xmlns:a="http://schemas.openxmlformats.org/drawingml/2006/main"/>
           <a:p xmlns:a="http://schemas.openxmlformats.org/drawingml/2006/main">
             <a:pPr algn="l">
+              <a:buNone/>
               <a:defRPr sz="2100" b="1">
                 <a:solidFill>
                   <a:srgbClr val="FF5A36"/>
@@ -5303,6 +5368,7 @@
           <a:lstStyle xmlns:a="http://schemas.openxmlformats.org/drawingml/2006/main"/>
           <a:p xmlns:a="http://schemas.openxmlformats.org/drawingml/2006/main">
             <a:pPr algn="l">
+              <a:buNone/>
               <a:defRPr sz="1650" b="0">
                 <a:solidFill>
                   <a:srgbClr val="111111"/>
@@ -5326,6 +5392,7 @@
           </a:p>
           <a:p xmlns:a="http://schemas.openxmlformats.org/drawingml/2006/main">
             <a:pPr algn="l">
+              <a:buNone/>
               <a:defRPr sz="1650" b="0">
                 <a:solidFill>
                   <a:srgbClr val="111111"/>
@@ -5383,6 +5450,7 @@
           <a:lstStyle xmlns:a="http://schemas.openxmlformats.org/drawingml/2006/main"/>
           <a:p xmlns:a="http://schemas.openxmlformats.org/drawingml/2006/main">
             <a:pPr algn="l">
+              <a:buNone/>
               <a:defRPr sz="2100" b="1">
                 <a:solidFill>
                   <a:srgbClr val="FF5A36"/>
@@ -5470,6 +5538,7 @@
           <a:lstStyle xmlns:a="http://schemas.openxmlformats.org/drawingml/2006/main"/>
           <a:p xmlns:a="http://schemas.openxmlformats.org/drawingml/2006/main">
             <a:pPr algn="l">
+              <a:buNone/>
               <a:defRPr sz="1650" b="0">
                 <a:solidFill>
                   <a:srgbClr val="111111"/>
@@ -5493,6 +5562,7 @@
           </a:p>
           <a:p xmlns:a="http://schemas.openxmlformats.org/drawingml/2006/main">
             <a:pPr algn="l">
+              <a:buNone/>
               <a:defRPr sz="1650" b="0">
                 <a:solidFill>
                   <a:srgbClr val="111111"/>
@@ -5550,6 +5620,7 @@
           <a:lstStyle xmlns:a="http://schemas.openxmlformats.org/drawingml/2006/main"/>
           <a:p xmlns:a="http://schemas.openxmlformats.org/drawingml/2006/main">
             <a:pPr algn="l">
+              <a:buNone/>
               <a:defRPr sz="2025" b="1">
                 <a:solidFill>
                   <a:srgbClr val="111111"/>
@@ -5607,6 +5678,7 @@
           <a:lstStyle xmlns:a="http://schemas.openxmlformats.org/drawingml/2006/main"/>
           <a:p xmlns:a="http://schemas.openxmlformats.org/drawingml/2006/main">
             <a:pPr algn="l">
+              <a:buNone/>
               <a:defRPr sz="675" b="0">
                 <a:solidFill>
                   <a:srgbClr val="8C887F"/>
@@ -5664,6 +5736,7 @@
           <a:lstStyle xmlns:a="http://schemas.openxmlformats.org/drawingml/2006/main"/>
           <a:p xmlns:a="http://schemas.openxmlformats.org/drawingml/2006/main">
             <a:pPr algn="r">
+              <a:buNone/>
               <a:defRPr sz="675" b="0">
                 <a:solidFill>
                   <a:srgbClr val="8C887F"/>
@@ -5750,6 +5823,7 @@
           <a:lstStyle xmlns:a="http://schemas.openxmlformats.org/drawingml/2006/main"/>
           <a:p xmlns:a="http://schemas.openxmlformats.org/drawingml/2006/main">
             <a:pPr algn="l">
+              <a:buNone/>
               <a:defRPr sz="3750" b="1">
                 <a:solidFill>
                   <a:srgbClr val="FFFFFF"/>
@@ -5807,6 +5881,7 @@
           <a:lstStyle xmlns:a="http://schemas.openxmlformats.org/drawingml/2006/main"/>
           <a:p xmlns:a="http://schemas.openxmlformats.org/drawingml/2006/main">
             <a:pPr algn="l">
+              <a:buNone/>
               <a:defRPr sz="3600" b="1">
                 <a:solidFill>
                   <a:srgbClr val="FF5A36"/>
@@ -5864,6 +5939,7 @@
           <a:lstStyle xmlns:a="http://schemas.openxmlformats.org/drawingml/2006/main"/>
           <a:p xmlns:a="http://schemas.openxmlformats.org/drawingml/2006/main">
             <a:pPr algn="l">
+              <a:buNone/>
               <a:defRPr sz="1500" b="1">
                 <a:solidFill>
                   <a:srgbClr val="AAA9A4"/>
@@ -5921,6 +5997,7 @@
           <a:lstStyle xmlns:a="http://schemas.openxmlformats.org/drawingml/2006/main"/>
           <a:p xmlns:a="http://schemas.openxmlformats.org/drawingml/2006/main">
             <a:pPr algn="l">
+              <a:buNone/>
               <a:defRPr sz="1725" b="0">
                 <a:solidFill>
                   <a:srgbClr val="FFFFFF"/>
@@ -5978,6 +6055,7 @@
           <a:lstStyle xmlns:a="http://schemas.openxmlformats.org/drawingml/2006/main"/>
           <a:p xmlns:a="http://schemas.openxmlformats.org/drawingml/2006/main">
             <a:pPr algn="l">
+              <a:buNone/>
               <a:defRPr sz="1500" b="1">
                 <a:solidFill>
                   <a:srgbClr val="AAA9A4"/>
@@ -6035,6 +6113,7 @@
           <a:lstStyle xmlns:a="http://schemas.openxmlformats.org/drawingml/2006/main"/>
           <a:p xmlns:a="http://schemas.openxmlformats.org/drawingml/2006/main">
             <a:pPr algn="l">
+              <a:buNone/>
               <a:defRPr sz="1875" b="0">
                 <a:solidFill>
                   <a:srgbClr val="FFFFFF"/>
@@ -6092,6 +6171,7 @@
           <a:lstStyle xmlns:a="http://schemas.openxmlformats.org/drawingml/2006/main"/>
           <a:p xmlns:a="http://schemas.openxmlformats.org/drawingml/2006/main">
             <a:pPr algn="l">
+              <a:buNone/>
               <a:defRPr sz="2250" b="1">
                 <a:solidFill>
                   <a:srgbClr val="FF5A36"/>
@@ -6149,6 +6229,7 @@
           <a:lstStyle xmlns:a="http://schemas.openxmlformats.org/drawingml/2006/main"/>
           <a:p xmlns:a="http://schemas.openxmlformats.org/drawingml/2006/main">
             <a:pPr algn="l">
+              <a:buNone/>
               <a:defRPr sz="900" b="0">
                 <a:solidFill>
                   <a:srgbClr val="9C9C97"/>
@@ -6206,6 +6287,7 @@
           <a:lstStyle xmlns:a="http://schemas.openxmlformats.org/drawingml/2006/main"/>
           <a:p xmlns:a="http://schemas.openxmlformats.org/drawingml/2006/main">
             <a:pPr algn="l">
+              <a:buNone/>
               <a:defRPr sz="675" b="0">
                 <a:solidFill>
                   <a:srgbClr val="777772"/>
@@ -6263,6 +6345,7 @@
           <a:lstStyle xmlns:a="http://schemas.openxmlformats.org/drawingml/2006/main"/>
           <a:p xmlns:a="http://schemas.openxmlformats.org/drawingml/2006/main">
             <a:pPr algn="r">
+              <a:buNone/>
               <a:defRPr sz="675" b="0">
                 <a:solidFill>
                   <a:srgbClr val="777772"/>

</xml_diff>